<commit_message>
Fixes (typos), added means to presentation
</commit_message>
<xml_diff>
--- a/Assignent2presentation.pptx
+++ b/Assignent2presentation.pptx
@@ -238,7 +238,7 @@
           <a:p>
             <a:fld id="{258BFD57-AB0A-470B-A7AF-56DFE7B5174A}" type="datetimeFigureOut">
               <a:rPr lang="en-US" smtClean="0"/>
-              <a:t>10/13/2026</a:t>
+              <a:t>10/14/2026</a:t>
             </a:fld>
             <a:endParaRPr lang="en-US" dirty="0"/>
           </a:p>
@@ -415,7 +415,7 @@
           <a:p>
             <a:fld id="{D4B3339F-6CEA-4641-BE08-40DAFD6FCF25}" type="datetimeFigureOut">
               <a:rPr lang="en-US" smtClean="0"/>
-              <a:t>10/13/2026</a:t>
+              <a:t>10/14/2026</a:t>
             </a:fld>
             <a:endParaRPr lang="en-US" dirty="0"/>
           </a:p>
@@ -10453,7 +10453,7 @@
           <a:p>
             <a:r>
               <a:rPr lang="hu-HU" dirty="0" err="1"/>
-              <a:t>Not</a:t>
+              <a:t>Clusters</a:t>
             </a:r>
             <a:r>
               <a:rPr lang="hu-HU" dirty="0"/>
@@ -10461,7 +10461,7 @@
             </a:r>
             <a:r>
               <a:rPr lang="hu-HU" dirty="0" err="1"/>
-              <a:t>too</a:t>
+              <a:t>not</a:t>
             </a:r>
             <a:r>
               <a:rPr lang="hu-HU" dirty="0"/>
@@ -10469,14 +10469,7 @@
             </a:r>
             <a:r>
               <a:rPr lang="hu-HU" dirty="0" err="1"/>
-              <a:t>compact</a:t>
-            </a:r>
-            <a:endParaRPr lang="hu-HU" dirty="0"/>
-          </a:p>
-          <a:p>
-            <a:r>
-              <a:rPr lang="hu-HU" dirty="0" err="1"/>
-              <a:t>Correspond</a:t>
+              <a:t>too</a:t>
             </a:r>
             <a:r>
               <a:rPr lang="hu-HU" dirty="0"/>
@@ -10484,7 +10477,46 @@
             </a:r>
             <a:r>
               <a:rPr lang="hu-HU" dirty="0" err="1"/>
+              <a:t>compact</a:t>
+            </a:r>
+            <a:endParaRPr lang="hu-HU" dirty="0"/>
+          </a:p>
+          <a:p>
+            <a:r>
+              <a:rPr lang="hu-HU" dirty="0" err="1"/>
+              <a:t>Corresponds</a:t>
+            </a:r>
+            <a:r>
+              <a:rPr lang="hu-HU" dirty="0"/>
+              <a:t> </a:t>
+            </a:r>
+            <a:r>
+              <a:rPr lang="hu-HU" dirty="0" err="1"/>
               <a:t>well</a:t>
+            </a:r>
+            <a:r>
+              <a:rPr lang="hu-HU" dirty="0"/>
+              <a:t> </a:t>
+            </a:r>
+            <a:r>
+              <a:rPr lang="hu-HU" dirty="0" err="1"/>
+              <a:t>to</a:t>
+            </a:r>
+            <a:r>
+              <a:rPr lang="hu-HU" dirty="0"/>
+              <a:t> </a:t>
+            </a:r>
+            <a:r>
+              <a:rPr lang="hu-HU" dirty="0" err="1"/>
+              <a:t>actual</a:t>
+            </a:r>
+            <a:r>
+              <a:rPr lang="hu-HU" dirty="0"/>
+              <a:t> </a:t>
+            </a:r>
+            <a:r>
+              <a:rPr lang="hu-HU" dirty="0" err="1"/>
+              <a:t>classes</a:t>
             </a:r>
             <a:endParaRPr lang="en-US" dirty="0"/>
           </a:p>
@@ -11152,7 +11184,7 @@
         </p:nvSpPr>
         <p:spPr>
           <a:xfrm>
-            <a:off x="733562" y="433906"/>
+            <a:off x="642122" y="445559"/>
             <a:ext cx="10515601" cy="1327464"/>
           </a:xfrm>
         </p:spPr>
@@ -11244,7 +11276,15 @@
             </a:r>
             <a:r>
               <a:rPr lang="hu-HU" sz="2400" dirty="0"/>
-              <a:t>5</a:t>
+              <a:t>5  (</a:t>
+            </a:r>
+            <a:r>
+              <a:rPr lang="hu-HU" sz="2400" dirty="0" err="1"/>
+              <a:t>Mean</a:t>
+            </a:r>
+            <a:r>
+              <a:rPr lang="hu-HU" sz="2400" dirty="0"/>
+              <a:t> = 0.561)</a:t>
             </a:r>
           </a:p>
           <a:p>
@@ -11276,7 +11316,18 @@
               <a:rPr lang="en-GB" sz="2400" dirty="0"/>
               <a:t>, 0.53, 0.59</a:t>
             </a:r>
-            <a:endParaRPr lang="hu-HU" sz="2400" dirty="0"/>
+            <a:r>
+              <a:rPr lang="hu-HU" sz="2400" dirty="0"/>
+              <a:t> (</a:t>
+            </a:r>
+            <a:r>
+              <a:rPr lang="hu-HU" sz="2400" dirty="0" err="1"/>
+              <a:t>Mean</a:t>
+            </a:r>
+            <a:r>
+              <a:rPr lang="hu-HU" sz="2400" dirty="0"/>
+              <a:t> = 0.485)</a:t>
+            </a:r>
           </a:p>
           <a:p>
             <a:r>
@@ -11308,7 +11359,15 @@
             </a:r>
             <a:r>
               <a:rPr lang="hu-HU" sz="2400" dirty="0"/>
-              <a:t>9</a:t>
+              <a:t>9 (</a:t>
+            </a:r>
+            <a:r>
+              <a:rPr lang="hu-HU" sz="2400" dirty="0" err="1"/>
+              <a:t>Mean</a:t>
+            </a:r>
+            <a:r>
+              <a:rPr lang="hu-HU" sz="2400" dirty="0"/>
+              <a:t> = 0.461)</a:t>
             </a:r>
           </a:p>
           <a:p>
@@ -11341,7 +11400,15 @@
             </a:r>
             <a:r>
               <a:rPr lang="hu-HU" sz="2400" dirty="0"/>
-              <a:t>0 …</a:t>
+              <a:t>0 … (</a:t>
+            </a:r>
+            <a:r>
+              <a:rPr lang="hu-HU" sz="2400" dirty="0" err="1"/>
+              <a:t>Mean</a:t>
+            </a:r>
+            <a:r>
+              <a:rPr lang="hu-HU" sz="2400" dirty="0"/>
+              <a:t> = 0.424)</a:t>
             </a:r>
           </a:p>
         </p:txBody>
@@ -11403,8 +11470,8 @@
         </p:blipFill>
         <p:spPr>
           <a:xfrm>
-            <a:off x="5821161" y="2859051"/>
-            <a:ext cx="5940674" cy="3765371"/>
+            <a:off x="6470408" y="1221595"/>
+            <a:ext cx="5536157" cy="3508976"/>
           </a:xfrm>
           <a:prstGeom prst="rect">
             <a:avLst/>
@@ -12375,35 +12442,6 @@
 </file>
 
 <file path=customXml/item1.xml><?xml version="1.0" encoding="utf-8"?>
-<p:properties xmlns:p="http://schemas.microsoft.com/office/2006/metadata/properties" xmlns:xsi="http://www.w3.org/2001/XMLSchema-instance" xmlns:pc="http://schemas.microsoft.com/office/infopath/2007/PartnerControls">
-  <documentManagement>
-    <_ip_UnifiedCompliancePolicyUIAction xmlns="http://schemas.microsoft.com/sharepoint/v3" xsi:nil="true"/>
-    <Image xmlns="71af3243-3dd4-4a8d-8c0d-dd76da1f02a5">
-      <Url xsi:nil="true"/>
-      <Description xsi:nil="true"/>
-    </Image>
-    <Status xmlns="71af3243-3dd4-4a8d-8c0d-dd76da1f02a5">Not started</Status>
-    <Background xmlns="71af3243-3dd4-4a8d-8c0d-dd76da1f02a5">false</Background>
-    <_ip_UnifiedCompliancePolicyProperties xmlns="http://schemas.microsoft.com/sharepoint/v3" xsi:nil="true"/>
-    <ImageTagsTaxHTField xmlns="71af3243-3dd4-4a8d-8c0d-dd76da1f02a5">
-      <Terms xmlns="http://schemas.microsoft.com/office/infopath/2007/PartnerControls"/>
-    </ImageTagsTaxHTField>
-    <TaxCatchAll xmlns="230e9df3-be65-4c73-a93b-d1236ebd677e" xsi:nil="true"/>
-    <MediaServiceKeyPoints xmlns="71af3243-3dd4-4a8d-8c0d-dd76da1f02a5" xsi:nil="true"/>
-  </documentManagement>
-</p:properties>
-</file>
-
-<file path=customXml/item2.xml><?xml version="1.0" encoding="utf-8"?>
-<?mso-contentType ?>
-<FormTemplates xmlns="http://schemas.microsoft.com/sharepoint/v3/contenttype/forms">
-  <Display>DocumentLibraryForm</Display>
-  <Edit>DocumentLibraryForm</Edit>
-  <New>DocumentLibraryForm</New>
-</FormTemplates>
-</file>
-
-<file path=customXml/item3.xml><?xml version="1.0" encoding="utf-8"?>
 <ct:contentTypeSchema xmlns:ct="http://schemas.microsoft.com/office/2006/metadata/contentType" xmlns:ma="http://schemas.microsoft.com/office/2006/metadata/properties/metaAttributes" ct:_="" ma:_="" ma:contentTypeName="Document" ma:contentTypeID="0x01010079F111ED35F8CC479449609E8A0923A6" ma:contentTypeVersion="28" ma:contentTypeDescription="Create a new document." ma:contentTypeScope="" ma:versionID="60f5a4f2d2b0abadcf532d48ebf9cb71">
   <xsd:schema xmlns:xsd="http://www.w3.org/2001/XMLSchema" xmlns:xs="http://www.w3.org/2001/XMLSchema" xmlns:p="http://schemas.microsoft.com/office/2006/metadata/properties" xmlns:ns1="http://schemas.microsoft.com/sharepoint/v3" xmlns:ns2="71af3243-3dd4-4a8d-8c0d-dd76da1f02a5" xmlns:ns3="16c05727-aa75-4e4a-9b5f-8a80a1165891" xmlns:ns4="230e9df3-be65-4c73-a93b-d1236ebd677e" targetNamespace="http://schemas.microsoft.com/office/2006/metadata/properties" ma:root="true" ma:fieldsID="7dd78129e6a1811f84807ad11c651531" ns1:_="" ns2:_="" ns3:_="" ns4:_="">
     <xsd:import namespace="http://schemas.microsoft.com/sharepoint/v3"/>
@@ -12715,27 +12753,36 @@
 </ct:contentTypeSchema>
 </file>
 
-<file path=customXml/itemProps1.xml><?xml version="1.0" encoding="utf-8"?>
-<ds:datastoreItem xmlns:ds="http://schemas.openxmlformats.org/officeDocument/2006/customXml" ds:itemID="{E305301E-11B3-4B9D-A588-21F3C9809371}">
-  <ds:schemaRefs>
-    <ds:schemaRef ds:uri="http://schemas.microsoft.com/office/2006/metadata/properties"/>
-    <ds:schemaRef ds:uri="http://schemas.microsoft.com/office/infopath/2007/PartnerControls"/>
-    <ds:schemaRef ds:uri="http://schemas.microsoft.com/sharepoint/v3"/>
-    <ds:schemaRef ds:uri="71af3243-3dd4-4a8d-8c0d-dd76da1f02a5"/>
-    <ds:schemaRef ds:uri="230e9df3-be65-4c73-a93b-d1236ebd677e"/>
-  </ds:schemaRefs>
-</ds:datastoreItem>
+<file path=customXml/item2.xml><?xml version="1.0" encoding="utf-8"?>
+<?mso-contentType ?>
+<FormTemplates xmlns="http://schemas.microsoft.com/sharepoint/v3/contenttype/forms">
+  <Display>DocumentLibraryForm</Display>
+  <Edit>DocumentLibraryForm</Edit>
+  <New>DocumentLibraryForm</New>
+</FormTemplates>
 </file>
 
-<file path=customXml/itemProps2.xml><?xml version="1.0" encoding="utf-8"?>
-<ds:datastoreItem xmlns:ds="http://schemas.openxmlformats.org/officeDocument/2006/customXml" ds:itemID="{44137456-21FC-4AE2-8A94-BF06CAF2EB9B}">
-  <ds:schemaRefs>
-    <ds:schemaRef ds:uri="http://schemas.microsoft.com/sharepoint/v3/contenttype/forms"/>
-  </ds:schemaRefs>
-</ds:datastoreItem>
+<file path=customXml/item3.xml><?xml version="1.0" encoding="utf-8"?>
+<p:properties xmlns:p="http://schemas.microsoft.com/office/2006/metadata/properties" xmlns:xsi="http://www.w3.org/2001/XMLSchema-instance" xmlns:pc="http://schemas.microsoft.com/office/infopath/2007/PartnerControls">
+  <documentManagement>
+    <_ip_UnifiedCompliancePolicyUIAction xmlns="http://schemas.microsoft.com/sharepoint/v3" xsi:nil="true"/>
+    <Image xmlns="71af3243-3dd4-4a8d-8c0d-dd76da1f02a5">
+      <Url xsi:nil="true"/>
+      <Description xsi:nil="true"/>
+    </Image>
+    <Status xmlns="71af3243-3dd4-4a8d-8c0d-dd76da1f02a5">Not started</Status>
+    <Background xmlns="71af3243-3dd4-4a8d-8c0d-dd76da1f02a5">false</Background>
+    <_ip_UnifiedCompliancePolicyProperties xmlns="http://schemas.microsoft.com/sharepoint/v3" xsi:nil="true"/>
+    <ImageTagsTaxHTField xmlns="71af3243-3dd4-4a8d-8c0d-dd76da1f02a5">
+      <Terms xmlns="http://schemas.microsoft.com/office/infopath/2007/PartnerControls"/>
+    </ImageTagsTaxHTField>
+    <TaxCatchAll xmlns="230e9df3-be65-4c73-a93b-d1236ebd677e" xsi:nil="true"/>
+    <MediaServiceKeyPoints xmlns="71af3243-3dd4-4a8d-8c0d-dd76da1f02a5" xsi:nil="true"/>
+  </documentManagement>
+</p:properties>
 </file>
 
-<file path=customXml/itemProps3.xml><?xml version="1.0" encoding="utf-8"?>
+<file path=customXml/itemProps1.xml><?xml version="1.0" encoding="utf-8"?>
 <ds:datastoreItem xmlns:ds="http://schemas.openxmlformats.org/officeDocument/2006/customXml" ds:itemID="{C77B561B-3A65-4A22-9691-EB838E7F9B87}">
   <ds:schemaRefs>
     <ds:schemaRef ds:uri="http://schemas.microsoft.com/office/2006/metadata/contentType"/>
@@ -12756,6 +12803,26 @@
 </ds:datastoreItem>
 </file>
 
+<file path=customXml/itemProps2.xml><?xml version="1.0" encoding="utf-8"?>
+<ds:datastoreItem xmlns:ds="http://schemas.openxmlformats.org/officeDocument/2006/customXml" ds:itemID="{44137456-21FC-4AE2-8A94-BF06CAF2EB9B}">
+  <ds:schemaRefs>
+    <ds:schemaRef ds:uri="http://schemas.microsoft.com/sharepoint/v3/contenttype/forms"/>
+  </ds:schemaRefs>
+</ds:datastoreItem>
+</file>
+
+<file path=customXml/itemProps3.xml><?xml version="1.0" encoding="utf-8"?>
+<ds:datastoreItem xmlns:ds="http://schemas.openxmlformats.org/officeDocument/2006/customXml" ds:itemID="{E305301E-11B3-4B9D-A588-21F3C9809371}">
+  <ds:schemaRefs>
+    <ds:schemaRef ds:uri="http://schemas.microsoft.com/office/2006/metadata/properties"/>
+    <ds:schemaRef ds:uri="http://schemas.microsoft.com/office/infopath/2007/PartnerControls"/>
+    <ds:schemaRef ds:uri="http://schemas.microsoft.com/sharepoint/v3"/>
+    <ds:schemaRef ds:uri="71af3243-3dd4-4a8d-8c0d-dd76da1f02a5"/>
+    <ds:schemaRef ds:uri="230e9df3-be65-4c73-a93b-d1236ebd677e"/>
+  </ds:schemaRefs>
+</ds:datastoreItem>
+</file>
+
 <file path=docMetadata/LabelInfo.xml><?xml version="1.0" encoding="utf-8"?>
 <clbl:labelList xmlns:clbl="http://schemas.microsoft.com/office/2020/mipLabelMetadata"/>
 </file>
</xml_diff>